<commit_message>
Add FMTV Lebanon entry to phase B transport section
Co-Authored-By: Claude Fable 5 <noreply@anthropic.com>
Claude-Session: https://claude.ai/code/session_01PzGxyg7vCW7954f4H7No6N
</commit_message>
<xml_diff>
--- a/אישור תוכניות מחט - מעודכן.pptx
+++ b/אישור תוכניות מחט - מעודכן.pptx
@@ -2050,6 +2050,26 @@
                 <a:cs typeface="Arial" pitchFamily="34" charset="-120"/>
               </a:rPr>
               <a:t>הובלות וניוד</a:t>
+            </a:r>
+          </a:p>
+          <a:p>
+            <a:pPr marL="127000" indent="-127000" algn="r" rtl="1">
+              <a:spcAft>
+                <a:spcPts val="500"/>
+              </a:spcAft>
+              <a:buSzPct val="100000"/>
+              <a:buChar char="•"/>
+            </a:pPr>
+            <a:r>
+              <a:rPr lang="he-IL" sz="1150" b="1" dirty="0">
+                <a:solidFill>
+                  <a:srgbClr val="26262B"/>
+                </a:solidFill>
+                <a:latin typeface="Arial" pitchFamily="34" charset="0"/>
+                <a:ea typeface="Arial" pitchFamily="34" charset="-122"/>
+                <a:cs typeface="Arial" pitchFamily="34" charset="-120"/>
+              </a:rPr>
+              <a:t>משאיות FMTV נכנסות ללבנון ב-22.9, מעמיסות את הגדוד בבוקר 23.9 ויוצאות</a:t>
             </a:r>
           </a:p>
           <a:p>

</xml_diff>

<commit_message>
Add Reo solar removal on 20.9 to phase B transport section
Co-Authored-By: Claude Fable 5 <noreply@anthropic.com>
Claude-Session: https://claude.ai/code/session_01PzGxyg7vCW7954f4H7No6N
</commit_message>
<xml_diff>
--- a/אישור תוכניות מחט - מעודכן.pptx
+++ b/אישור תוכניות מחט - מעודכן.pptx
@@ -2050,6 +2050,26 @@
                 <a:cs typeface="Arial" pitchFamily="34" charset="-120"/>
               </a:rPr>
               <a:t>הובלות וניוד</a:t>
+            </a:r>
+          </a:p>
+          <a:p>
+            <a:pPr marL="127000" indent="-127000" algn="r" rtl="1">
+              <a:spcAft>
+                <a:spcPts val="500"/>
+              </a:spcAft>
+              <a:buSzPct val="100000"/>
+              <a:buChar char="•"/>
+            </a:pPr>
+            <a:r>
+              <a:rPr lang="he-IL" sz="1150" dirty="0">
+                <a:solidFill>
+                  <a:srgbClr val="26262B"/>
+                </a:solidFill>
+                <a:latin typeface="Arial" pitchFamily="34" charset="0"/>
+                <a:ea typeface="Arial" pitchFamily="34" charset="-122"/>
+                <a:cs typeface="Arial" pitchFamily="34" charset="-120"/>
+              </a:rPr>
+              <a:t>הוצאת ריו סולר ביום א' 20.9</a:t>
             </a:r>
           </a:p>
           <a:p>

</xml_diff>

<commit_message>
Add vehicle and fuel tanker gap card to readiness gaps slide
Co-Authored-By: Claude Fable 5 <noreply@anthropic.com>
Claude-Session: https://claude.ai/code/session_01PzGxyg7vCW7954f4H7No6N
</commit_message>
<xml_diff>
--- a/אישור תוכניות מחט - מעודכן.pptx
+++ b/אישור תוכניות מחט - מעודכן.pptx
@@ -15554,8 +15554,8 @@
         </p:nvSpPr>
         <p:spPr>
           <a:xfrm>
-            <a:off x="548640" y="1380000"/>
-            <a:ext cx="10588752" cy="900000"/>
+            <a:off x="548640" y="1325880"/>
+            <a:ext cx="10588752" cy="749808"/>
           </a:xfrm>
           <a:prstGeom prst="roundRect">
             <a:avLst>
@@ -15583,7 +15583,7 @@
         </p:nvSpPr>
         <p:spPr>
           <a:xfrm>
-            <a:off x="9171432" y="1624260"/>
+            <a:off x="9171432" y="1495044"/>
             <a:ext cx="1783080" cy="411480"/>
           </a:xfrm>
           <a:prstGeom prst="roundRect">
@@ -15612,7 +15612,7 @@
         </p:nvSpPr>
         <p:spPr>
           <a:xfrm>
-            <a:off x="9171432" y="1624260"/>
+            <a:off x="9171432" y="1495044"/>
             <a:ext cx="1783080" cy="411480"/>
           </a:xfrm>
           <a:prstGeom prst="rect">
@@ -15651,8 +15651,8 @@
         </p:nvSpPr>
         <p:spPr>
           <a:xfrm>
-            <a:off x="731520" y="1440000"/>
-            <a:ext cx="8211312" cy="780000"/>
+            <a:off x="731520" y="1371600"/>
+            <a:ext cx="8211312" cy="658368"/>
           </a:xfrm>
           <a:prstGeom prst="rect">
             <a:avLst/>
@@ -15707,8 +15707,8 @@
         </p:nvSpPr>
         <p:spPr>
           <a:xfrm>
-            <a:off x="548640" y="2385000"/>
-            <a:ext cx="10588752" cy="900000"/>
+            <a:off x="548640" y="2167128"/>
+            <a:ext cx="10588752" cy="749808"/>
           </a:xfrm>
           <a:prstGeom prst="roundRect">
             <a:avLst>
@@ -15736,7 +15736,7 @@
         </p:nvSpPr>
         <p:spPr>
           <a:xfrm>
-            <a:off x="9171432" y="2629260"/>
+            <a:off x="9171432" y="2336292"/>
             <a:ext cx="1783080" cy="411480"/>
           </a:xfrm>
           <a:prstGeom prst="roundRect">
@@ -15765,7 +15765,7 @@
         </p:nvSpPr>
         <p:spPr>
           <a:xfrm>
-            <a:off x="9171432" y="2629260"/>
+            <a:off x="9171432" y="2336292"/>
             <a:ext cx="1783080" cy="411480"/>
           </a:xfrm>
           <a:prstGeom prst="rect">
@@ -15804,8 +15804,8 @@
         </p:nvSpPr>
         <p:spPr>
           <a:xfrm>
-            <a:off x="731520" y="2445000"/>
-            <a:ext cx="8211312" cy="780000"/>
+            <a:off x="731520" y="2212848"/>
+            <a:ext cx="8211312" cy="658368"/>
           </a:xfrm>
           <a:prstGeom prst="rect">
             <a:avLst/>
@@ -16005,8 +16005,8 @@
         </p:nvSpPr>
         <p:spPr>
           <a:xfrm>
-            <a:off x="548640" y="3390000"/>
-            <a:ext cx="10588752" cy="900000"/>
+            <a:off x="548640" y="3008376"/>
+            <a:ext cx="10588752" cy="749808"/>
           </a:xfrm>
           <a:prstGeom prst="roundRect">
             <a:avLst>
@@ -16034,7 +16034,7 @@
         </p:nvSpPr>
         <p:spPr>
           <a:xfrm>
-            <a:off x="9171432" y="3634260"/>
+            <a:off x="9171432" y="3177540"/>
             <a:ext cx="1783080" cy="411480"/>
           </a:xfrm>
           <a:prstGeom prst="roundRect">
@@ -16063,7 +16063,7 @@
         </p:nvSpPr>
         <p:spPr>
           <a:xfrm>
-            <a:off x="9171432" y="3634260"/>
+            <a:off x="9171432" y="3177540"/>
             <a:ext cx="1783080" cy="411480"/>
           </a:xfrm>
           <a:prstGeom prst="rect">
@@ -16102,8 +16102,8 @@
         </p:nvSpPr>
         <p:spPr>
           <a:xfrm>
-            <a:off x="731520" y="3450000"/>
-            <a:ext cx="8211312" cy="780000"/>
+            <a:off x="731520" y="3054096"/>
+            <a:ext cx="8211312" cy="658368"/>
           </a:xfrm>
           <a:prstGeom prst="rect">
             <a:avLst/>
@@ -16365,8 +16365,8 @@
         </p:nvSpPr>
         <p:spPr>
           <a:xfrm>
-            <a:off x="548640" y="4395000"/>
-            <a:ext cx="10588752" cy="900000"/>
+            <a:off x="548640" y="3849624"/>
+            <a:ext cx="10588752" cy="749808"/>
           </a:xfrm>
           <a:prstGeom prst="roundRect">
             <a:avLst>
@@ -16394,7 +16394,7 @@
         </p:nvSpPr>
         <p:spPr>
           <a:xfrm>
-            <a:off x="9171432" y="4639260"/>
+            <a:off x="9171432" y="4018787"/>
             <a:ext cx="1783080" cy="411480"/>
           </a:xfrm>
           <a:prstGeom prst="roundRect">
@@ -16423,7 +16423,7 @@
         </p:nvSpPr>
         <p:spPr>
           <a:xfrm>
-            <a:off x="9171432" y="4639260"/>
+            <a:off x="9171432" y="4018787"/>
             <a:ext cx="1783080" cy="411480"/>
           </a:xfrm>
           <a:prstGeom prst="rect">
@@ -16462,8 +16462,8 @@
         </p:nvSpPr>
         <p:spPr>
           <a:xfrm>
-            <a:off x="731520" y="4455000"/>
-            <a:ext cx="8211312" cy="780000"/>
+            <a:off x="731520" y="3895344"/>
+            <a:ext cx="8211312" cy="658368"/>
           </a:xfrm>
           <a:prstGeom prst="rect">
             <a:avLst/>
@@ -16562,8 +16562,8 @@
         </p:nvSpPr>
         <p:spPr>
           <a:xfrm>
-            <a:off x="548640" y="5400000"/>
-            <a:ext cx="10588752" cy="900000"/>
+            <a:off x="548640" y="4690872"/>
+            <a:ext cx="10588752" cy="749808"/>
           </a:xfrm>
           <a:prstGeom prst="roundRect">
             <a:avLst>
@@ -16591,7 +16591,7 @@
         </p:nvSpPr>
         <p:spPr>
           <a:xfrm>
-            <a:off x="9171432" y="5644260"/>
+            <a:off x="9171432" y="4860036"/>
             <a:ext cx="1783080" cy="411480"/>
           </a:xfrm>
           <a:prstGeom prst="roundRect">
@@ -16620,7 +16620,7 @@
         </p:nvSpPr>
         <p:spPr>
           <a:xfrm>
-            <a:off x="9171432" y="5644260"/>
+            <a:off x="9171432" y="4860036"/>
             <a:ext cx="1783080" cy="411480"/>
           </a:xfrm>
           <a:prstGeom prst="rect">
@@ -16659,8 +16659,8 @@
         </p:nvSpPr>
         <p:spPr>
           <a:xfrm>
-            <a:off x="731520" y="5460000"/>
-            <a:ext cx="8211312" cy="780000"/>
+            <a:off x="731520" y="4736592"/>
+            <a:ext cx="8211312" cy="658368"/>
           </a:xfrm>
           <a:prstGeom prst="rect">
             <a:avLst/>
@@ -16736,6 +16736,157 @@
               <a:t> ציוד מתקרית הפיצוץ.</a:t>
             </a:r>
             <a:endParaRPr lang="en-US" sz="1250" b="1" dirty="0"/>
+          </a:p>
+        </p:txBody>
+      </p:sp>
+      <p:sp>
+        <p:nvSpPr>
+          <p:cNvPr id="28" name="Card 6 bg"/>
+          <p:cNvSpPr/>
+          <p:nvPr/>
+        </p:nvSpPr>
+        <p:spPr>
+          <a:xfrm>
+            <a:off x="548640" y="5532120"/>
+            <a:ext cx="10588752" cy="749808"/>
+          </a:xfrm>
+          <a:prstGeom prst="roundRect">
+            <a:avLst>
+              <a:gd name="adj" fmla="val 5217"/>
+            </a:avLst>
+          </a:prstGeom>
+          <a:solidFill>
+            <a:srgbClr val="F2F2F2"/>
+          </a:solidFill>
+          <a:ln/>
+        </p:spPr>
+        <p:txBody>
+          <a:bodyPr/>
+          <a:lstStyle/>
+          <a:p>
+            <a:endParaRPr lang="he-IL"/>
+          </a:p>
+        </p:txBody>
+      </p:sp>
+      <p:sp>
+        <p:nvSpPr>
+          <p:cNvPr id="29" name="Card 6 pill"/>
+          <p:cNvSpPr/>
+          <p:nvPr/>
+        </p:nvSpPr>
+        <p:spPr>
+          <a:xfrm>
+            <a:off x="9171432" y="5701284"/>
+            <a:ext cx="1783080" cy="411480"/>
+          </a:xfrm>
+          <a:prstGeom prst="roundRect">
+            <a:avLst>
+              <a:gd name="adj" fmla="val 13333"/>
+            </a:avLst>
+          </a:prstGeom>
+          <a:solidFill>
+            <a:srgbClr val="9B1B1F"/>
+          </a:solidFill>
+          <a:ln/>
+        </p:spPr>
+        <p:txBody>
+          <a:bodyPr/>
+          <a:lstStyle/>
+          <a:p>
+            <a:endParaRPr lang="he-IL"/>
+          </a:p>
+        </p:txBody>
+      </p:sp>
+      <p:sp>
+        <p:nvSpPr>
+          <p:cNvPr id="30" name="Card 6 pill text"/>
+          <p:cNvSpPr txBox="1"/>
+          <p:nvPr/>
+        </p:nvSpPr>
+        <p:spPr>
+          <a:xfrm>
+            <a:off x="9171432" y="5701284"/>
+            <a:ext cx="1783080" cy="411480"/>
+          </a:xfrm>
+          <a:prstGeom prst="rect">
+            <a:avLst/>
+          </a:prstGeom>
+          <a:noFill/>
+          <a:ln/>
+        </p:spPr>
+        <p:txBody>
+          <a:bodyPr wrap="square" lIns="0" tIns="0" rIns="0" bIns="0" rtlCol="0" anchor="ctr"/>
+          <a:lstStyle/>
+          <a:p>
+            <a:pPr algn="ctr" rtl="1"/>
+            <a:r>
+              <a:rPr lang="he-IL" sz="1300" b="1" dirty="0">
+                <a:solidFill>
+                  <a:srgbClr val="FFFFFF"/>
+                </a:solidFill>
+                <a:latin typeface="Arial" pitchFamily="34" charset="0"/>
+                <a:cs typeface="Arial" pitchFamily="34" charset="-120"/>
+              </a:rPr>
+              <a:t>רכב ומיכלית</a:t>
+            </a:r>
+          </a:p>
+        </p:txBody>
+      </p:sp>
+      <p:sp>
+        <p:nvSpPr>
+          <p:cNvPr id="31" name="Card 6 text"/>
+          <p:cNvSpPr txBox="1"/>
+          <p:nvPr/>
+        </p:nvSpPr>
+        <p:spPr>
+          <a:xfrm>
+            <a:off x="731520" y="5577840"/>
+            <a:ext cx="8211312" cy="658368"/>
+          </a:xfrm>
+          <a:prstGeom prst="rect">
+            <a:avLst/>
+          </a:prstGeom>
+          <a:noFill/>
+          <a:ln/>
+        </p:spPr>
+        <p:txBody>
+          <a:bodyPr wrap="square" lIns="0" tIns="0" rIns="0" bIns="0" rtlCol="0" anchor="ctr"/>
+          <a:lstStyle/>
+          <a:p>
+            <a:pPr algn="r" rtl="1">
+              <a:spcAft>
+                <a:spcPts val="300"/>
+              </a:spcAft>
+            </a:pPr>
+            <a:r>
+              <a:rPr lang="he-IL" sz="1250" b="1" dirty="0">
+                <a:solidFill>
+                  <a:srgbClr val="26262B"/>
+                </a:solidFill>
+                <a:latin typeface="Arial" pitchFamily="34" charset="0"/>
+                <a:ea typeface="Arial" pitchFamily="34" charset="-122"/>
+                <a:cs typeface="Arial" pitchFamily="34" charset="-120"/>
+              </a:rPr>
+              <a:t>מבקשים להשאיר רכב יר"מ 1 או לקבל רכב לבן מהחטיבה - להמשך ליווי 2 הפצועים שעדיין בשיבא.</a:t>
+            </a:r>
+          </a:p>
+          <a:p>
+            <a:pPr algn="r" rtl="1">
+              <a:spcAft>
+                <a:spcPts val="300"/>
+              </a:spcAft>
+            </a:pPr>
+            <a:r>
+              <a:rPr lang="he-IL" sz="1250" dirty="0">
+                <a:solidFill>
+                  <a:srgbClr val="26262B"/>
+                </a:solidFill>
+                <a:latin typeface="Arial" pitchFamily="34" charset="0"/>
+                <a:ea typeface="Arial" pitchFamily="34" charset="-122"/>
+                <a:cs typeface="Arial" pitchFamily="34" charset="-120"/>
+              </a:rPr>
+              <a:t>גדוד מהיר מחייב מיכלית סולר.</a:t>
+            </a:r>
           </a:p>
         </p:txBody>
       </p:sp>

</xml_diff>